<commit_message>
Unify project links under FP10 organization repository
</commit_message>
<xml_diff>
--- a/submission/PS2-FP10-StayOrSwitch-A0-Poster.pptx
+++ b/submission/PS2-FP10-StayOrSwitch-A0-Poster.pptx
@@ -2,13 +2,13 @@
 <file path=ppt/presentation.xml><?xml version="1.0" encoding="utf-8"?>
 <p:presentation xmlns:p="http://schemas.openxmlformats.org/presentationml/2006/main">
   <p:sldMasterIdLst>
-    <p:sldMasterId xmlns:r="http://schemas.openxmlformats.org/officeDocument/2006/relationships" id="2147483648" r:id="R7c14c3f924594dd9"/>
+    <p:sldMasterId xmlns:r="http://schemas.openxmlformats.org/officeDocument/2006/relationships" id="2147483648" r:id="Rcd4e96050e914672"/>
   </p:sldMasterIdLst>
   <p:notesMasterIdLst>
-    <p:notesMasterId xmlns:r="http://schemas.openxmlformats.org/officeDocument/2006/relationships" r:id="R23147fca8ce0470b"/>
+    <p:notesMasterId xmlns:r="http://schemas.openxmlformats.org/officeDocument/2006/relationships" r:id="R000b9c0b42684a4e"/>
   </p:notesMasterIdLst>
   <p:sldIdLst>
-    <p:sldId xmlns:r="http://schemas.openxmlformats.org/officeDocument/2006/relationships" id="256" r:id="Re2548633f1f04a14"/>
+    <p:sldId xmlns:r="http://schemas.openxmlformats.org/officeDocument/2006/relationships" id="256" r:id="Ra9569c90fdbf4181"/>
   </p:sldIdLst>
   <p:sldSz cx="42804000" cy="30276000"/>
   <p:notesSz cx="6858000" cy="9144000"/>
@@ -465,8 +465,8 @@
               <a:t>
 Poster evidence record, review-ready v1:
 Paper baseline: commit 43a2941184d8130852af3c1f88fc90e8b2fd9fc6.
-Model/output evidence: ps2_memory_portability/outputs and tests at snapshot f9523b0.
-Public URLs returned HTTP 200 on 2026-09-26: https://huggingface.co/spaces/mickeystk/ps2-stay-or-switch-memory-portability and https://github.com/micL1222/gt-tools-demos/tree/ps2-memory-portability.
+Model/output evidence: outputs and tests in https://github.com/dku-comsci-econ206-Autumn2026/FP10-StayOrSwitch-Yiqiao; historical baseline f9523b0.
+Public URLs returned HTTP 200 on 2026-09-27: https://huggingface.co/spaces/mickeystk/ps2-stay-or-switch-memory-portability and https://github.com/dku-comsci-econ206-Autumn2026/FP10-StayOrSwitch-Yiqiao.
 QR targets were generated locally and decoded back to the displayed URLs.
 No participant result, symposium feedback, or classroom auction-play evidence is claimed.</a:t>
             </a:r>
@@ -536,7 +536,7 @@
   </p:cSld>
   <p:clrMap bg1="lt1" tx1="dk1" bg2="lt2" tx2="dk2" accent1="accent1" accent2="accent2" accent3="accent3" accent4="accent4" accent5="accent5" accent6="accent6" hlink="hlink" folHlink="folHlink"/>
   <p:sldLayoutIdLst>
-    <p:sldLayoutId xmlns:r="http://schemas.openxmlformats.org/officeDocument/2006/relationships" id="2147483649" r:id="Re2d74641e5aa4c53"/>
+    <p:sldLayoutId xmlns:r="http://schemas.openxmlformats.org/officeDocument/2006/relationships" id="2147483649" r:id="R3f68583aac3343e9"/>
   </p:sldLayoutIdLst>
   <p:txStyles>
     <p:titleStyle>
@@ -1447,7 +1447,7 @@
           <p:nvPr/>
         </p:nvPicPr>
         <p:blipFill>
-          <a:blip xmlns:r="http://schemas.openxmlformats.org/officeDocument/2006/relationships" xmlns:a="http://schemas.openxmlformats.org/drawingml/2006/main" r:embed="R92e132de09d74efe"/>
+          <a:blip xmlns:r="http://schemas.openxmlformats.org/officeDocument/2006/relationships" xmlns:a="http://schemas.openxmlformats.org/drawingml/2006/main" r:embed="R02061a2b3fae4b4d"/>
           <a:stretch xmlns:a="http://schemas.openxmlformats.org/drawingml/2006/main"/>
         </p:blipFill>
         <p:spPr>
@@ -3095,7 +3095,7 @@
                 <a:ea typeface="Calibri"/>
                 <a:cs typeface="Calibri"/>
               </a:rPr>
-              <a:t>Verified outputs at GitHub snapshot f9523b0.</a:t>
+              <a:t>Verified outputs in the canonical FP10 repository.</a:t>
             </a:r>
           </a:p>
           <a:p xmlns:a="http://schemas.openxmlformats.org/drawingml/2006/main">
@@ -4615,7 +4615,7 @@
                 <a:latin typeface="Calibri"/>
                 <a:ea typeface="Calibri"/>
                 <a:cs typeface="Calibri"/>
-                <a:hlinkClick xmlns:r="http://schemas.openxmlformats.org/officeDocument/2006/relationships" r:id="Rb8a159f94fed4ef4"/>
+                <a:hlinkClick xmlns:r="http://schemas.openxmlformats.org/officeDocument/2006/relationships" r:id="R9842e4bf0d0f4b12"/>
               </a:rPr>
               <a:t>https://huggingface.co/spaces/mickeystk/ps2-stay-or-switch-memory-portability</a:t>
             </a:r>
@@ -4654,9 +4654,9 @@
                 <a:latin typeface="Calibri"/>
                 <a:ea typeface="Calibri"/>
                 <a:cs typeface="Calibri"/>
-                <a:hlinkClick xmlns:r="http://schemas.openxmlformats.org/officeDocument/2006/relationships" r:id="Rea1ccce1007a4470"/>
-              </a:rPr>
-              <a:t>https://github.com/micL1222/gt-tools-demos/tree/ps2-memory-portability</a:t>
+                <a:hlinkClick xmlns:r="http://schemas.openxmlformats.org/officeDocument/2006/relationships" r:id="R14ed4fb935e4422e"/>
+              </a:rPr>
+              <a:t>https://github.com/dku-comsci-econ206-Autumn2026/FP10-StayOrSwitch-Yiqiao</a:t>
             </a:r>
           </a:p>
         </p:txBody>
@@ -4909,7 +4909,7 @@
           <p:cNvPr id="54" name="diagram-economics">
             <a:extLst xmlns:a="http://schemas.openxmlformats.org/drawingml/2006/main">
               <a:ext uri="{FF2B5EF4-FFF2-40B4-BE49-F238E27FC236}">
-                <a16:creationId xmlns:a16="http://schemas.microsoft.com/office/drawing/2014/main" id="{E5712E2E-A70B-4E74-A24E-457AC242A211}"/>
+                <a16:creationId xmlns:a16="http://schemas.microsoft.com/office/drawing/2014/main" id="{7543723B-D402-44DF-85CE-0A88C5164BD0}"/>
               </a:ext>
             </a:extLst>
           </p:cNvPr>
@@ -4997,7 +4997,7 @@
           <p:cNvPr id="55" name="diagram-computation">
             <a:extLst xmlns:a="http://schemas.openxmlformats.org/drawingml/2006/main">
               <a:ext uri="{FF2B5EF4-FFF2-40B4-BE49-F238E27FC236}">
-                <a16:creationId xmlns:a16="http://schemas.microsoft.com/office/drawing/2014/main" id="{B86FB873-19C3-4DD9-8FD5-C9828D190BB9}"/>
+                <a16:creationId xmlns:a16="http://schemas.microsoft.com/office/drawing/2014/main" id="{B25036BC-C3E1-4C59-B515-EC2C8425C80A}"/>
               </a:ext>
             </a:extLst>
           </p:cNvPr>
@@ -5085,7 +5085,7 @@
           <p:cNvPr id="56" name="diagram-behavior">
             <a:extLst xmlns:a="http://schemas.openxmlformats.org/drawingml/2006/main">
               <a:ext uri="{FF2B5EF4-FFF2-40B4-BE49-F238E27FC236}">
-                <a16:creationId xmlns:a16="http://schemas.microsoft.com/office/drawing/2014/main" id="{E8B3A3A9-F1CF-4C10-A82B-F376D7D30726}"/>
+                <a16:creationId xmlns:a16="http://schemas.microsoft.com/office/drawing/2014/main" id="{FB4D2C59-D5D3-4E2D-AF25-AD4F046CB831}"/>
               </a:ext>
             </a:extLst>
           </p:cNvPr>
@@ -5225,7 +5225,7 @@
           <p:cNvPr id="59" name="diagram-synthesis">
             <a:extLst xmlns:a="http://schemas.openxmlformats.org/drawingml/2006/main">
               <a:ext uri="{FF2B5EF4-FFF2-40B4-BE49-F238E27FC236}">
-                <a16:creationId xmlns:a16="http://schemas.microsoft.com/office/drawing/2014/main" id="{66C083E9-3BB9-4C9C-809B-AB5C2215EF4C}"/>
+                <a16:creationId xmlns:a16="http://schemas.microsoft.com/office/drawing/2014/main" id="{2100C076-2164-40A6-9B30-E59194475AA9}"/>
               </a:ext>
             </a:extLst>
           </p:cNvPr>
@@ -5678,7 +5678,7 @@
           <p:nvPr/>
         </p:nvPicPr>
         <p:blipFill>
-          <a:blip xmlns:r="http://schemas.openxmlformats.org/officeDocument/2006/relationships" xmlns:a="http://schemas.openxmlformats.org/drawingml/2006/main" r:embed="Radaebb3361a843cb"/>
+          <a:blip xmlns:r="http://schemas.openxmlformats.org/officeDocument/2006/relationships" xmlns:a="http://schemas.openxmlformats.org/drawingml/2006/main" r:embed="R9a07f428b8ff422d"/>
           <a:stretch xmlns:a="http://schemas.openxmlformats.org/drawingml/2006/main"/>
         </p:blipFill>
         <p:spPr>
@@ -5700,7 +5700,7 @@
           <p:nvPr/>
         </p:nvPicPr>
         <p:blipFill>
-          <a:blip xmlns:r="http://schemas.openxmlformats.org/officeDocument/2006/relationships" xmlns:a="http://schemas.openxmlformats.org/drawingml/2006/main" r:embed="R37133774fc3b4ab2"/>
+          <a:blip xmlns:r="http://schemas.openxmlformats.org/officeDocument/2006/relationships" xmlns:a="http://schemas.openxmlformats.org/drawingml/2006/main" r:embed="R7dd02a0cbf4c4ad9"/>
           <a:stretch xmlns:a="http://schemas.openxmlformats.org/drawingml/2006/main"/>
         </p:blipFill>
         <p:spPr>

</xml_diff>